<commit_message>
vault backup: 2026-06-02 01:12:58
</commit_message>
<xml_diff>
--- a/A1《白穹纪元：机械永生录》/商业材料/白穹纪元路演PPT.pptx
+++ b/A1《白穹纪元：机械永生录》/商业材料/白穹纪元路演PPT.pptx
@@ -4,6 +4,9 @@
   <p:sldMasterIdLst>
     <p:sldMasterId id="2147483648" r:id="rId1"/>
   </p:sldMasterIdLst>
+  <p:notesMasterIdLst>
+    <p:notesMasterId r:id="rId15"/>
+  </p:notesMasterIdLst>
   <p:sldIdLst>
     <p:sldId id="256" r:id="rId2"/>
     <p:sldId id="257" r:id="rId3"/>
@@ -19,10 +22,7 @@
     <p:sldId id="267" r:id="rId13"/>
     <p:sldId id="268" r:id="rId14"/>
   </p:sldIdLst>
-  <p:notesMasterIdLst>
-    <p:notesMasterId r:id="rId15"/>
-  </p:notesMasterIdLst>
-  <p:sldSz cx="9144000" cy="5143500"/>
+  <p:sldSz cx="9144000" cy="5143500" type="screen16x9"/>
   <p:notesSz cx="5143500" cy="9144000"/>
   <p:defaultTextStyle>
     <a:lvl1pPr marL="0" algn="l" defTabSz="914400" rtl="0" eaLnBrk="1" latinLnBrk="0" hangingPunct="1">
@@ -116,6 +116,11 @@
       </a:defRPr>
     </a:lvl9pPr>
   </p:defaultTextStyle>
+  <p:extLst>
+    <p:ext uri="{EFAFB233-063F-42B5-8137-9DF3F51BA10A}">
+      <p15:sldGuideLst xmlns:p15="http://schemas.microsoft.com/office/powerpoint/2012/main"/>
+    </p:ext>
+  </p:extLst>
 </p:presentation>
 </file>
 
@@ -141,234 +146,10 @@
           <a:chExt cx="0" cy="0"/>
         </a:xfrm>
       </p:grpSpPr>
-      <p:sp>
-        <p:nvSpPr>
-          <p:cNvPr id="2" name="Header Placeholder 1"/>
-          <p:cNvSpPr>
-            <a:spLocks noGrp="1"/>
-          </p:cNvSpPr>
-          <p:nvPr>
-            <p:ph type="hdr" sz="quarter"/>
-          </p:nvPr>
-        </p:nvSpPr>
-        <p:spPr>
-          <a:xfrm>
-            <a:off x="0" y="0"/>
-            <a:ext cx="2971800" cy="458788"/>
-          </a:xfrm>
-          <a:prstGeom prst="rect">
-            <a:avLst/>
-          </a:prstGeom>
-        </p:spPr>
-        <p:txBody>
-          <a:bodyPr vert="horz" lIns="91440" tIns="45720" rIns="91440" bIns="45720" rtlCol="0"/>
-          <a:lstStyle>
-            <a:lvl1pPr algn="l">
-              <a:defRPr sz="1200"/>
-            </a:lvl1pPr>
-          </a:lstStyle>
-          <a:p>
-            <a:endParaRPr lang="en-US"/>
-          </a:p>
-        </p:txBody>
-      </p:sp>
-      <p:sp>
-        <p:nvSpPr>
-          <p:cNvPr id="3" name="Date Placeholder 2"/>
-          <p:cNvSpPr>
-            <a:spLocks noGrp="1"/>
-          </p:cNvSpPr>
-          <p:nvPr>
-            <p:ph type="dt" idx="1"/>
-          </p:nvPr>
-        </p:nvSpPr>
-        <p:spPr>
-          <a:xfrm>
-            <a:off x="3884613" y="0"/>
-            <a:ext cx="2971800" cy="458788"/>
-          </a:xfrm>
-          <a:prstGeom prst="rect">
-            <a:avLst/>
-          </a:prstGeom>
-        </p:spPr>
-        <p:txBody>
-          <a:bodyPr vert="horz" lIns="91440" tIns="45720" rIns="91440" bIns="45720" rtlCol="0"/>
-          <a:lstStyle>
-            <a:lvl1pPr algn="r">
-              <a:defRPr sz="1200"/>
-            </a:lvl1pPr>
-          </a:lstStyle>
-          <a:p>
-            <a:fld id="{5282F153-3F37-0F45-9E97-73ACFA13230C}" type="datetimeFigureOut">
-              <a:rPr lang="en-US"/>
-              <a:t>7/23/19</a:t>
-            </a:fld>
-            <a:endParaRPr lang="en-US"/>
-          </a:p>
-        </p:txBody>
-      </p:sp>
-      <p:sp>
-        <p:nvSpPr>
-          <p:cNvPr id="4" name="Slide Image Placeholder 3"/>
-          <p:cNvSpPr>
-            <a:spLocks noGrp="1" noRot="1" noChangeAspect="1"/>
-          </p:cNvSpPr>
-          <p:nvPr>
-            <p:ph type="sldImg" idx="2"/>
-          </p:nvPr>
-        </p:nvSpPr>
-        <p:spPr>
-          <a:xfrm>
-            <a:off x="685800" y="1143000"/>
-            <a:ext cx="5486400" cy="3086100"/>
-          </a:xfrm>
-          <a:prstGeom prst="rect">
-            <a:avLst/>
-          </a:prstGeom>
-          <a:noFill/>
-          <a:ln w="12700">
-            <a:solidFill>
-              <a:prstClr val="black"/>
-            </a:solidFill>
-          </a:ln>
-        </p:spPr>
-        <p:txBody>
-          <a:bodyPr vert="horz" lIns="91440" tIns="45720" rIns="91440" bIns="45720" rtlCol="0" anchor="ctr"/>
-          <a:lstStyle/>
-          <a:p>
-            <a:endParaRPr lang="en-US"/>
-          </a:p>
-        </p:txBody>
-      </p:sp>
-      <p:sp>
-        <p:nvSpPr>
-          <p:cNvPr id="5" name="Notes Placeholder 4"/>
-          <p:cNvSpPr>
-            <a:spLocks noGrp="1"/>
-          </p:cNvSpPr>
-          <p:nvPr>
-            <p:ph type="body" sz="quarter" idx="3"/>
-          </p:nvPr>
-        </p:nvSpPr>
-        <p:spPr>
-          <a:xfrm>
-            <a:off x="685800" y="4400550"/>
-            <a:ext cx="5486400" cy="3600450"/>
-          </a:xfrm>
-          <a:prstGeom prst="rect">
-            <a:avLst/>
-          </a:prstGeom>
-        </p:spPr>
-        <p:txBody>
-          <a:bodyPr vert="horz" lIns="91440" tIns="45720" rIns="91440" bIns="45720" rtlCol="0"/>
-          <a:lstStyle/>
-          <a:p>
-            <a:pPr lvl="0"/>
-            <a:r>
-              <a:rPr lang="en-US"/>
-              <a:t>Click to edit Master text styles</a:t>
-            </a:r>
-          </a:p>
-          <a:p>
-            <a:pPr lvl="1"/>
-            <a:r>
-              <a:rPr lang="en-US"/>
-              <a:t>Second level</a:t>
-            </a:r>
-          </a:p>
-          <a:p>
-            <a:pPr lvl="2"/>
-            <a:r>
-              <a:rPr lang="en-US"/>
-              <a:t>Third level</a:t>
-            </a:r>
-          </a:p>
-          <a:p>
-            <a:pPr lvl="3"/>
-            <a:r>
-              <a:rPr lang="en-US"/>
-              <a:t>Fourth level</a:t>
-            </a:r>
-          </a:p>
-          <a:p>
-            <a:pPr lvl="4"/>
-            <a:r>
-              <a:rPr lang="en-US"/>
-              <a:t>Fifth level</a:t>
-            </a:r>
-          </a:p>
-        </p:txBody>
-      </p:sp>
-      <p:sp>
-        <p:nvSpPr>
-          <p:cNvPr id="6" name="Footer Placeholder 5"/>
-          <p:cNvSpPr>
-            <a:spLocks noGrp="1"/>
-          </p:cNvSpPr>
-          <p:nvPr>
-            <p:ph type="ftr" sz="quarter" idx="4"/>
-          </p:nvPr>
-        </p:nvSpPr>
-        <p:spPr>
-          <a:xfrm>
-            <a:off x="0" y="8685213"/>
-            <a:ext cx="2971800" cy="458787"/>
-          </a:xfrm>
-          <a:prstGeom prst="rect">
-            <a:avLst/>
-          </a:prstGeom>
-        </p:spPr>
-        <p:txBody>
-          <a:bodyPr vert="horz" lIns="91440" tIns="45720" rIns="91440" bIns="45720" rtlCol="0" anchor="b"/>
-          <a:lstStyle>
-            <a:lvl1pPr algn="l">
-              <a:defRPr sz="1200"/>
-            </a:lvl1pPr>
-          </a:lstStyle>
-          <a:p>
-            <a:endParaRPr lang="en-US"/>
-          </a:p>
-        </p:txBody>
-      </p:sp>
-      <p:sp>
-        <p:nvSpPr>
-          <p:cNvPr id="7" name="Slide Number Placeholder 6"/>
-          <p:cNvSpPr>
-            <a:spLocks noGrp="1"/>
-          </p:cNvSpPr>
-          <p:nvPr>
-            <p:ph type="sldNum" sz="quarter" idx="5"/>
-          </p:nvPr>
-        </p:nvSpPr>
-        <p:spPr>
-          <a:xfrm>
-            <a:off x="3884613" y="8685213"/>
-            <a:ext cx="2971800" cy="458787"/>
-          </a:xfrm>
-          <a:prstGeom prst="rect">
-            <a:avLst/>
-          </a:prstGeom>
-        </p:spPr>
-        <p:txBody>
-          <a:bodyPr vert="horz" lIns="91440" tIns="45720" rIns="91440" bIns="45720" rtlCol="0" anchor="b"/>
-          <a:lstStyle>
-            <a:lvl1pPr algn="r">
-              <a:defRPr sz="1200"/>
-            </a:lvl1pPr>
-          </a:lstStyle>
-          <a:p>
-            <a:fld id="{CE5E9CC1-C706-0F49-92D6-E571CC5EEA8F}" type="slidenum">
-              <a:rPr lang="en-US"/>
-              <a:t>‹#›</a:t>
-            </a:fld>
-            <a:endParaRPr lang="en-US"/>
-          </a:p>
-        </p:txBody>
-      </p:sp>
     </p:spTree>
     <p:extLst>
       <p:ext uri="{BB962C8B-B14F-4D97-AF65-F5344CB8AC3E}">
-        <p14:creationId xmlns:p14="http://schemas.microsoft.com/office/powerpoint/2010/main" val="1024086991"/>
+        <p14:creationId xmlns:p14="http://schemas.microsoft.com/office/powerpoint/2010/main" val="186647934"/>
       </p:ext>
     </p:extLst>
   </p:cSld>
@@ -512,10 +293,6 @@
           <a:bodyPr/>
           <a:lstStyle/>
           <a:p>
-            <a:r>
-              <a:rPr lang="en-US" dirty="0"/>
-              <a:t/>
-            </a:r>
             <a:endParaRPr lang="en-US" dirty="0"/>
           </a:p>
         </p:txBody>
@@ -600,10 +377,6 @@
           <a:bodyPr/>
           <a:lstStyle/>
           <a:p>
-            <a:r>
-              <a:rPr lang="en-US" dirty="0"/>
-              <a:t/>
-            </a:r>
             <a:endParaRPr lang="en-US" dirty="0"/>
           </a:p>
         </p:txBody>
@@ -688,10 +461,6 @@
           <a:bodyPr/>
           <a:lstStyle/>
           <a:p>
-            <a:r>
-              <a:rPr lang="en-US" dirty="0"/>
-              <a:t/>
-            </a:r>
             <a:endParaRPr lang="en-US" dirty="0"/>
           </a:p>
         </p:txBody>
@@ -776,10 +545,6 @@
           <a:bodyPr/>
           <a:lstStyle/>
           <a:p>
-            <a:r>
-              <a:rPr lang="en-US" dirty="0"/>
-              <a:t/>
-            </a:r>
             <a:endParaRPr lang="en-US" dirty="0"/>
           </a:p>
         </p:txBody>
@@ -864,10 +629,6 @@
           <a:bodyPr/>
           <a:lstStyle/>
           <a:p>
-            <a:r>
-              <a:rPr lang="en-US" dirty="0"/>
-              <a:t/>
-            </a:r>
             <a:endParaRPr lang="en-US" dirty="0"/>
           </a:p>
         </p:txBody>
@@ -952,10 +713,6 @@
           <a:bodyPr/>
           <a:lstStyle/>
           <a:p>
-            <a:r>
-              <a:rPr lang="en-US" dirty="0"/>
-              <a:t/>
-            </a:r>
             <a:endParaRPr lang="en-US" dirty="0"/>
           </a:p>
         </p:txBody>
@@ -1040,10 +797,6 @@
           <a:bodyPr/>
           <a:lstStyle/>
           <a:p>
-            <a:r>
-              <a:rPr lang="en-US" dirty="0"/>
-              <a:t/>
-            </a:r>
             <a:endParaRPr lang="en-US" dirty="0"/>
           </a:p>
         </p:txBody>
@@ -1128,10 +881,6 @@
           <a:bodyPr/>
           <a:lstStyle/>
           <a:p>
-            <a:r>
-              <a:rPr lang="en-US" dirty="0"/>
-              <a:t/>
-            </a:r>
             <a:endParaRPr lang="en-US" dirty="0"/>
           </a:p>
         </p:txBody>
@@ -1216,10 +965,6 @@
           <a:bodyPr/>
           <a:lstStyle/>
           <a:p>
-            <a:r>
-              <a:rPr lang="en-US" dirty="0"/>
-              <a:t/>
-            </a:r>
             <a:endParaRPr lang="en-US" dirty="0"/>
           </a:p>
         </p:txBody>
@@ -1304,10 +1049,6 @@
           <a:bodyPr/>
           <a:lstStyle/>
           <a:p>
-            <a:r>
-              <a:rPr lang="en-US" dirty="0"/>
-              <a:t/>
-            </a:r>
             <a:endParaRPr lang="en-US" dirty="0"/>
           </a:p>
         </p:txBody>
@@ -1392,10 +1133,6 @@
           <a:bodyPr/>
           <a:lstStyle/>
           <a:p>
-            <a:r>
-              <a:rPr lang="en-US" dirty="0"/>
-              <a:t/>
-            </a:r>
             <a:endParaRPr lang="en-US" dirty="0"/>
           </a:p>
         </p:txBody>
@@ -1480,10 +1217,6 @@
           <a:bodyPr/>
           <a:lstStyle/>
           <a:p>
-            <a:r>
-              <a:rPr lang="en-US" dirty="0"/>
-              <a:t/>
-            </a:r>
             <a:endParaRPr lang="en-US" dirty="0"/>
           </a:p>
         </p:txBody>
@@ -1568,10 +1301,6 @@
           <a:bodyPr/>
           <a:lstStyle/>
           <a:p>
-            <a:r>
-              <a:rPr lang="en-US" dirty="0"/>
-              <a:t/>
-            </a:r>
             <a:endParaRPr lang="en-US" dirty="0"/>
           </a:p>
         </p:txBody>
@@ -1645,6 +1374,11 @@
 <file path=ppt/slideMasters/slideMaster1.xml><?xml version="1.0" encoding="utf-8"?>
 <p:sldMaster xmlns:a="http://schemas.openxmlformats.org/drawingml/2006/main" xmlns:r="http://schemas.openxmlformats.org/officeDocument/2006/relationships" xmlns:p="http://schemas.openxmlformats.org/presentationml/2006/main">
   <p:cSld>
+    <p:bg>
+      <p:bgRef idx="1001">
+        <a:schemeClr val="bg1"/>
+      </p:bgRef>
+    </p:bg>
     <p:spTree>
       <p:nvGrpSpPr>
         <p:cNvPr id="1" name=""/>
@@ -2002,11 +1736,11 @@
           <a:bodyPr wrap="square" rtlCol="0" anchor="ctr"/>
           <a:lstStyle/>
           <a:p>
-            <a:pPr algn="ctr" indent="0" marL="0">
-              <a:buNone/>
-            </a:pPr>
-            <a:r>
-              <a:rPr lang="en-US" sz="1400" spc="600" kern="0" dirty="0">
+            <a:pPr marL="0" indent="0" algn="ctr">
+              <a:buNone/>
+            </a:pPr>
+            <a:r>
+              <a:rPr lang="en-US" sz="1400" kern="0" spc="600" dirty="0">
                 <a:solidFill>
                   <a:srgbClr val="4CAF50"/>
                 </a:solidFill>
@@ -2041,7 +1775,7 @@
           <a:bodyPr wrap="square" rtlCol="0" anchor="ctr"/>
           <a:lstStyle/>
           <a:p>
-            <a:pPr algn="ctr" indent="0" marL="0">
+            <a:pPr marL="0" indent="0" algn="ctr">
               <a:buNone/>
             </a:pPr>
             <a:r>
@@ -2080,7 +1814,7 @@
           <a:bodyPr wrap="square" rtlCol="0" anchor="ctr"/>
           <a:lstStyle/>
           <a:p>
-            <a:pPr algn="ctr" indent="0" marL="0">
+            <a:pPr marL="0" indent="0" algn="ctr">
               <a:buNone/>
             </a:pPr>
             <a:r>
@@ -2142,7 +1876,7 @@
           <a:bodyPr wrap="square" rtlCol="0" anchor="ctr"/>
           <a:lstStyle/>
           <a:p>
-            <a:pPr algn="ctr" indent="0" marL="0">
+            <a:pPr marL="0" indent="0" algn="ctr">
               <a:buNone/>
             </a:pPr>
             <a:r>
@@ -2226,11 +1960,11 @@
           <a:bodyPr wrap="square" rtlCol="0" anchor="ctr"/>
           <a:lstStyle/>
           <a:p>
-            <a:pPr indent="0" marL="0">
-              <a:buNone/>
-            </a:pPr>
-            <a:r>
-              <a:rPr lang="en-US" sz="1000" spc="400" kern="0" dirty="0">
+            <a:pPr marL="0" indent="0">
+              <a:buNone/>
+            </a:pPr>
+            <a:r>
+              <a:rPr lang="en-US" sz="1000" kern="0" spc="400" dirty="0">
                 <a:solidFill>
                   <a:srgbClr val="4CAF50"/>
                 </a:solidFill>
@@ -2265,7 +1999,7 @@
           <a:bodyPr wrap="square" rtlCol="0" anchor="ctr"/>
           <a:lstStyle/>
           <a:p>
-            <a:pPr indent="0" marL="0">
+            <a:pPr marL="0" indent="0">
               <a:buNone/>
             </a:pPr>
             <a:r>
@@ -2304,7 +2038,7 @@
           <a:bodyPr wrap="square" rtlCol="0" anchor="ctr"/>
           <a:lstStyle/>
           <a:p>
-            <a:pPr indent="0" marL="0">
+            <a:pPr marL="0" indent="0">
               <a:buNone/>
             </a:pPr>
             <a:r>
@@ -2343,7 +2077,7 @@
           <a:bodyPr wrap="square" rtlCol="0" anchor="ctr"/>
           <a:lstStyle/>
           <a:p>
-            <a:pPr indent="0" marL="0">
+            <a:pPr marL="0" indent="0">
               <a:buNone/>
             </a:pPr>
             <a:r>
@@ -2382,7 +2116,7 @@
           <a:bodyPr wrap="square" rtlCol="0" anchor="ctr"/>
           <a:lstStyle/>
           <a:p>
-            <a:pPr indent="0" marL="0">
+            <a:pPr marL="0" indent="0">
               <a:buNone/>
             </a:pPr>
             <a:r>
@@ -2421,7 +2155,7 @@
           <a:bodyPr wrap="square" rtlCol="0" anchor="ctr"/>
           <a:lstStyle/>
           <a:p>
-            <a:pPr indent="0" marL="0">
+            <a:pPr marL="0" indent="0">
               <a:buNone/>
             </a:pPr>
             <a:r>
@@ -2460,7 +2194,7 @@
           <a:bodyPr wrap="square" rtlCol="0" anchor="ctr"/>
           <a:lstStyle/>
           <a:p>
-            <a:pPr indent="0" marL="0">
+            <a:pPr marL="0" indent="0">
               <a:buNone/>
             </a:pPr>
             <a:r>
@@ -2499,7 +2233,7 @@
           <a:bodyPr wrap="square" rtlCol="0" anchor="ctr"/>
           <a:lstStyle/>
           <a:p>
-            <a:pPr indent="0" marL="0">
+            <a:pPr marL="0" indent="0">
               <a:buNone/>
             </a:pPr>
             <a:r>
@@ -2538,7 +2272,7 @@
           <a:bodyPr wrap="square" rtlCol="0" anchor="ctr"/>
           <a:lstStyle/>
           <a:p>
-            <a:pPr indent="0" marL="0">
+            <a:pPr marL="0" indent="0">
               <a:buNone/>
             </a:pPr>
             <a:r>
@@ -2577,7 +2311,7 @@
           <a:bodyPr wrap="square" rtlCol="0" anchor="ctr"/>
           <a:lstStyle/>
           <a:p>
-            <a:pPr indent="0" marL="0">
+            <a:pPr marL="0" indent="0">
               <a:buNone/>
             </a:pPr>
             <a:r>
@@ -2639,7 +2373,7 @@
           <a:bodyPr wrap="square" rtlCol="0" anchor="ctr"/>
           <a:lstStyle/>
           <a:p>
-            <a:pPr indent="0" marL="0">
+            <a:pPr marL="0" indent="0">
               <a:buNone/>
             </a:pPr>
             <a:r>
@@ -2678,7 +2412,7 @@
           <a:bodyPr wrap="square" rtlCol="0" anchor="ctr"/>
           <a:lstStyle/>
           <a:p>
-            <a:pPr indent="0" marL="0">
+            <a:pPr marL="0" indent="0">
               <a:buNone/>
             </a:pPr>
             <a:r>
@@ -2690,7 +2424,7 @@
                 <a:ea typeface="Arial" pitchFamily="34" charset="-122"/>
                 <a:cs typeface="Arial" pitchFamily="34" charset="-120"/>
               </a:rPr>
-              <a:t>¥68x30万 + ¥98x15万 + DLC+内购 约4500万（保守估计）</a:t>
+              <a:t>¥68x30万 + ¥98x15万 + DLC+内购 约4510万（保守估计）</a:t>
             </a:r>
             <a:endParaRPr lang="en-US" sz="1200" dirty="0"/>
           </a:p>
@@ -2717,7 +2451,7 @@
           <a:bodyPr wrap="square" rtlCol="0" anchor="ctr"/>
           <a:lstStyle/>
           <a:p>
-            <a:pPr algn="r" indent="0" marL="0">
+            <a:pPr marL="0" indent="0" algn="r">
               <a:buNone/>
             </a:pPr>
             <a:r>
@@ -2801,11 +2535,11 @@
           <a:bodyPr wrap="square" rtlCol="0" anchor="ctr"/>
           <a:lstStyle/>
           <a:p>
-            <a:pPr indent="0" marL="0">
-              <a:buNone/>
-            </a:pPr>
-            <a:r>
-              <a:rPr lang="en-US" sz="1000" spc="400" kern="0" dirty="0">
+            <a:pPr marL="0" indent="0">
+              <a:buNone/>
+            </a:pPr>
+            <a:r>
+              <a:rPr lang="en-US" sz="1000" kern="0" spc="400" dirty="0">
                 <a:solidFill>
                   <a:srgbClr val="4CAF50"/>
                 </a:solidFill>
@@ -2840,7 +2574,7 @@
           <a:bodyPr wrap="square" rtlCol="0" anchor="ctr"/>
           <a:lstStyle/>
           <a:p>
-            <a:pPr indent="0" marL="0">
+            <a:pPr marL="0" indent="0">
               <a:buNone/>
             </a:pPr>
             <a:r>
@@ -2879,7 +2613,7 @@
           <a:bodyPr wrap="square" rtlCol="0" anchor="ctr"/>
           <a:lstStyle/>
           <a:p>
-            <a:pPr indent="0" marL="0">
+            <a:pPr marL="0" indent="0">
               <a:buNone/>
             </a:pPr>
             <a:r>
@@ -2918,7 +2652,7 @@
           <a:bodyPr wrap="square" rtlCol="0" anchor="ctr"/>
           <a:lstStyle/>
           <a:p>
-            <a:pPr indent="0" marL="0">
+            <a:pPr marL="0" indent="0">
               <a:buNone/>
             </a:pPr>
             <a:r>
@@ -2957,7 +2691,7 @@
           <a:bodyPr wrap="square" rtlCol="0" anchor="ctr"/>
           <a:lstStyle/>
           <a:p>
-            <a:pPr indent="0" marL="0">
+            <a:pPr marL="0" indent="0">
               <a:buNone/>
             </a:pPr>
             <a:r>
@@ -2996,7 +2730,7 @@
           <a:bodyPr wrap="square" rtlCol="0" anchor="ctr"/>
           <a:lstStyle/>
           <a:p>
-            <a:pPr algn="r" indent="0" marL="0">
+            <a:pPr marL="0" indent="0" algn="r">
               <a:buNone/>
             </a:pPr>
             <a:r>
@@ -3075,7 +2809,7 @@
           <a:bodyPr wrap="square" rtlCol="0" anchor="ctr"/>
           <a:lstStyle/>
           <a:p>
-            <a:pPr indent="0" marL="0">
+            <a:pPr marL="0" indent="0">
               <a:buNone/>
             </a:pPr>
             <a:r>
@@ -3114,7 +2848,7 @@
           <a:bodyPr wrap="square" rtlCol="0" anchor="ctr"/>
           <a:lstStyle/>
           <a:p>
-            <a:pPr indent="0" marL="0">
+            <a:pPr marL="0" indent="0">
               <a:buNone/>
             </a:pPr>
             <a:r>
@@ -3153,7 +2887,7 @@
           <a:bodyPr wrap="square" rtlCol="0" anchor="ctr"/>
           <a:lstStyle/>
           <a:p>
-            <a:pPr indent="0" marL="0">
+            <a:pPr marL="0" indent="0">
               <a:buNone/>
             </a:pPr>
             <a:r>
@@ -3192,7 +2926,7 @@
           <a:bodyPr wrap="square" rtlCol="0" anchor="ctr"/>
           <a:lstStyle/>
           <a:p>
-            <a:pPr algn="r" indent="0" marL="0">
+            <a:pPr marL="0" indent="0" algn="r">
               <a:buNone/>
             </a:pPr>
             <a:r>
@@ -3271,7 +3005,7 @@
           <a:bodyPr wrap="square" rtlCol="0" anchor="ctr"/>
           <a:lstStyle/>
           <a:p>
-            <a:pPr indent="0" marL="0">
+            <a:pPr marL="0" indent="0">
               <a:buNone/>
             </a:pPr>
             <a:r>
@@ -3310,7 +3044,7 @@
           <a:bodyPr wrap="square" rtlCol="0" anchor="ctr"/>
           <a:lstStyle/>
           <a:p>
-            <a:pPr indent="0" marL="0">
+            <a:pPr marL="0" indent="0">
               <a:buNone/>
             </a:pPr>
             <a:r>
@@ -3349,7 +3083,7 @@
           <a:bodyPr wrap="square" rtlCol="0" anchor="ctr"/>
           <a:lstStyle/>
           <a:p>
-            <a:pPr indent="0" marL="0">
+            <a:pPr marL="0" indent="0">
               <a:buNone/>
             </a:pPr>
             <a:r>
@@ -3388,7 +3122,7 @@
           <a:bodyPr wrap="square" rtlCol="0" anchor="ctr"/>
           <a:lstStyle/>
           <a:p>
-            <a:pPr algn="r" indent="0" marL="0">
+            <a:pPr marL="0" indent="0" algn="r">
               <a:buNone/>
             </a:pPr>
             <a:r>
@@ -3467,7 +3201,7 @@
           <a:bodyPr wrap="square" rtlCol="0" anchor="ctr"/>
           <a:lstStyle/>
           <a:p>
-            <a:pPr indent="0" marL="0">
+            <a:pPr marL="0" indent="0">
               <a:buNone/>
             </a:pPr>
             <a:r>
@@ -3506,7 +3240,7 @@
           <a:bodyPr wrap="square" rtlCol="0" anchor="ctr"/>
           <a:lstStyle/>
           <a:p>
-            <a:pPr indent="0" marL="0">
+            <a:pPr marL="0" indent="0">
               <a:buNone/>
             </a:pPr>
             <a:r>
@@ -3545,7 +3279,7 @@
           <a:bodyPr wrap="square" rtlCol="0" anchor="ctr"/>
           <a:lstStyle/>
           <a:p>
-            <a:pPr indent="0" marL="0">
+            <a:pPr marL="0" indent="0">
               <a:buNone/>
             </a:pPr>
             <a:r>
@@ -3584,7 +3318,7 @@
           <a:bodyPr wrap="square" rtlCol="0" anchor="ctr"/>
           <a:lstStyle/>
           <a:p>
-            <a:pPr algn="r" indent="0" marL="0">
+            <a:pPr marL="0" indent="0" algn="r">
               <a:buNone/>
             </a:pPr>
             <a:r>
@@ -3663,7 +3397,7 @@
           <a:bodyPr wrap="square" rtlCol="0" anchor="ctr"/>
           <a:lstStyle/>
           <a:p>
-            <a:pPr indent="0" marL="0">
+            <a:pPr marL="0" indent="0">
               <a:buNone/>
             </a:pPr>
             <a:r>
@@ -3702,7 +3436,7 @@
           <a:bodyPr wrap="square" rtlCol="0" anchor="ctr"/>
           <a:lstStyle/>
           <a:p>
-            <a:pPr indent="0" marL="0">
+            <a:pPr marL="0" indent="0">
               <a:buNone/>
             </a:pPr>
             <a:r>
@@ -3741,7 +3475,7 @@
           <a:bodyPr wrap="square" rtlCol="0" anchor="ctr"/>
           <a:lstStyle/>
           <a:p>
-            <a:pPr indent="0" marL="0">
+            <a:pPr marL="0" indent="0">
               <a:buNone/>
             </a:pPr>
             <a:r>
@@ -3780,7 +3514,7 @@
           <a:bodyPr wrap="square" rtlCol="0" anchor="ctr"/>
           <a:lstStyle/>
           <a:p>
-            <a:pPr algn="r" indent="0" marL="0">
+            <a:pPr marL="0" indent="0" algn="r">
               <a:buNone/>
             </a:pPr>
             <a:r>
@@ -3859,7 +3593,7 @@
           <a:bodyPr wrap="square" rtlCol="0" anchor="ctr"/>
           <a:lstStyle/>
           <a:p>
-            <a:pPr algn="ctr" indent="0" marL="0">
+            <a:pPr marL="0" indent="0" algn="ctr">
               <a:buNone/>
             </a:pPr>
             <a:r>
@@ -3898,7 +3632,7 @@
           <a:bodyPr wrap="square" rtlCol="0" anchor="ctr"/>
           <a:lstStyle/>
           <a:p>
-            <a:pPr algn="r" indent="0" marL="0">
+            <a:pPr marL="0" indent="0" algn="r">
               <a:buNone/>
             </a:pPr>
             <a:r>
@@ -3982,11 +3716,11 @@
           <a:bodyPr wrap="square" rtlCol="0" anchor="ctr"/>
           <a:lstStyle/>
           <a:p>
-            <a:pPr indent="0" marL="0">
-              <a:buNone/>
-            </a:pPr>
-            <a:r>
-              <a:rPr lang="en-US" sz="1000" spc="400" kern="0" dirty="0">
+            <a:pPr marL="0" indent="0">
+              <a:buNone/>
+            </a:pPr>
+            <a:r>
+              <a:rPr lang="en-US" sz="1000" kern="0" spc="400" dirty="0">
                 <a:solidFill>
                   <a:srgbClr val="4CAF50"/>
                 </a:solidFill>
@@ -4021,7 +3755,7 @@
           <a:bodyPr wrap="square" rtlCol="0" anchor="ctr"/>
           <a:lstStyle/>
           <a:p>
-            <a:pPr indent="0" marL="0">
+            <a:pPr marL="0" indent="0">
               <a:buNone/>
             </a:pPr>
             <a:r>
@@ -4060,7 +3794,7 @@
           <a:bodyPr wrap="square" rtlCol="0" anchor="ctr"/>
           <a:lstStyle/>
           <a:p>
-            <a:pPr indent="0" marL="0">
+            <a:pPr marL="0" indent="0">
               <a:buNone/>
             </a:pPr>
             <a:r>
@@ -4099,7 +3833,7 @@
           <a:bodyPr wrap="square" rtlCol="0" anchor="ctr"/>
           <a:lstStyle/>
           <a:p>
-            <a:pPr indent="0" marL="0">
+            <a:pPr marL="0" indent="0">
               <a:buNone/>
             </a:pPr>
             <a:r>
@@ -4138,7 +3872,7 @@
           <a:bodyPr wrap="square" rtlCol="0" anchor="ctr"/>
           <a:lstStyle/>
           <a:p>
-            <a:pPr indent="0" marL="0">
+            <a:pPr marL="0" indent="0">
               <a:buNone/>
             </a:pPr>
             <a:r>
@@ -4197,7 +3931,7 @@
           <a:bodyPr wrap="square" rtlCol="0" anchor="ctr"/>
           <a:lstStyle/>
           <a:p>
-            <a:pPr indent="0" marL="0">
+            <a:pPr marL="0" indent="0">
               <a:buNone/>
             </a:pPr>
             <a:r>
@@ -4256,7 +3990,7 @@
           <a:bodyPr wrap="square" rtlCol="0" anchor="ctr"/>
           <a:lstStyle/>
           <a:p>
-            <a:pPr indent="0" marL="0">
+            <a:pPr marL="0" indent="0">
               <a:buNone/>
             </a:pPr>
             <a:r>
@@ -4315,7 +4049,7 @@
           <a:bodyPr wrap="square" rtlCol="0" anchor="ctr"/>
           <a:lstStyle/>
           <a:p>
-            <a:pPr indent="0" marL="0">
+            <a:pPr marL="0" indent="0">
               <a:buNone/>
             </a:pPr>
             <a:r>
@@ -4374,7 +4108,7 @@
           <a:bodyPr wrap="square" rtlCol="0" anchor="ctr"/>
           <a:lstStyle/>
           <a:p>
-            <a:pPr indent="0" marL="0">
+            <a:pPr marL="0" indent="0">
               <a:buNone/>
             </a:pPr>
             <a:r>
@@ -4413,7 +4147,7 @@
           <a:bodyPr wrap="square" rtlCol="0" anchor="ctr"/>
           <a:lstStyle/>
           <a:p>
-            <a:pPr algn="r" indent="0" marL="0">
+            <a:pPr marL="0" indent="0" algn="r">
               <a:buNone/>
             </a:pPr>
             <a:r>
@@ -4497,7 +4231,7 @@
           <a:bodyPr wrap="square" rtlCol="0" anchor="ctr"/>
           <a:lstStyle/>
           <a:p>
-            <a:pPr algn="ctr" indent="0" marL="0">
+            <a:pPr marL="0" indent="0" algn="ctr">
               <a:buNone/>
             </a:pPr>
             <a:r>
@@ -4536,7 +4270,7 @@
           <a:bodyPr wrap="square" rtlCol="0" anchor="ctr"/>
           <a:lstStyle/>
           <a:p>
-            <a:pPr algn="ctr" indent="0" marL="0">
+            <a:pPr marL="0" indent="0" algn="ctr">
               <a:buNone/>
             </a:pPr>
             <a:r>
@@ -4598,7 +4332,7 @@
           <a:bodyPr wrap="square" rtlCol="0" anchor="ctr"/>
           <a:lstStyle/>
           <a:p>
-            <a:pPr algn="ctr" indent="0" marL="0">
+            <a:pPr marL="0" indent="0" algn="ctr">
               <a:buNone/>
             </a:pPr>
             <a:r>
@@ -4637,7 +4371,7 @@
           <a:bodyPr wrap="square" rtlCol="0" anchor="ctr"/>
           <a:lstStyle/>
           <a:p>
-            <a:pPr algn="r" indent="0" marL="0">
+            <a:pPr marL="0" indent="0" algn="r">
               <a:buNone/>
             </a:pPr>
             <a:r>
@@ -4721,7 +4455,7 @@
           <a:bodyPr wrap="square" rtlCol="0" anchor="ctr"/>
           <a:lstStyle/>
           <a:p>
-            <a:pPr algn="ctr" indent="0" marL="0">
+            <a:pPr marL="0" indent="0" algn="ctr">
               <a:buNone/>
             </a:pPr>
             <a:r>
@@ -4760,7 +4494,7 @@
           <a:bodyPr wrap="square" rtlCol="0" anchor="ctr"/>
           <a:lstStyle/>
           <a:p>
-            <a:pPr algn="ctr" indent="0" marL="0">
+            <a:pPr marL="0" indent="0" algn="ctr">
               <a:buNone/>
             </a:pPr>
             <a:r>
@@ -4822,7 +4556,7 @@
           <a:bodyPr wrap="square" rtlCol="0" anchor="ctr"/>
           <a:lstStyle/>
           <a:p>
-            <a:pPr algn="r" indent="0" marL="0">
+            <a:pPr marL="0" indent="0" algn="r">
               <a:buNone/>
             </a:pPr>
             <a:r>
@@ -4906,11 +4640,11 @@
           <a:bodyPr wrap="square" rtlCol="0" anchor="ctr"/>
           <a:lstStyle/>
           <a:p>
-            <a:pPr indent="0" marL="0">
-              <a:buNone/>
-            </a:pPr>
-            <a:r>
-              <a:rPr lang="en-US" sz="1000" spc="400" kern="0" dirty="0">
+            <a:pPr marL="0" indent="0">
+              <a:buNone/>
+            </a:pPr>
+            <a:r>
+              <a:rPr lang="en-US" sz="1000" kern="0" spc="400" dirty="0">
                 <a:solidFill>
                   <a:srgbClr val="4CAF50"/>
                 </a:solidFill>
@@ -4945,7 +4679,7 @@
           <a:bodyPr wrap="square" rtlCol="0" anchor="ctr"/>
           <a:lstStyle/>
           <a:p>
-            <a:pPr indent="0" marL="0">
+            <a:pPr marL="0" indent="0">
               <a:buNone/>
             </a:pPr>
             <a:r>
@@ -5004,7 +4738,7 @@
           <a:bodyPr wrap="square" rtlCol="0" anchor="ctr"/>
           <a:lstStyle/>
           <a:p>
-            <a:pPr indent="0" marL="0">
+            <a:pPr marL="0" indent="0">
               <a:buNone/>
             </a:pPr>
             <a:r>
@@ -5043,7 +4777,7 @@
           <a:bodyPr wrap="square" rtlCol="0" anchor="ctr"/>
           <a:lstStyle/>
           <a:p>
-            <a:pPr indent="0" marL="0">
+            <a:pPr marL="0" indent="0">
               <a:buNone/>
             </a:pPr>
             <a:r>
@@ -5102,7 +4836,7 @@
           <a:bodyPr wrap="square" rtlCol="0" anchor="ctr"/>
           <a:lstStyle/>
           <a:p>
-            <a:pPr indent="0" marL="0">
+            <a:pPr marL="0" indent="0">
               <a:buNone/>
             </a:pPr>
             <a:r>
@@ -5141,7 +4875,7 @@
           <a:bodyPr wrap="square" rtlCol="0" anchor="ctr"/>
           <a:lstStyle/>
           <a:p>
-            <a:pPr indent="0" marL="0">
+            <a:pPr marL="0" indent="0">
               <a:buNone/>
             </a:pPr>
             <a:r>
@@ -5200,7 +4934,7 @@
           <a:bodyPr wrap="square" rtlCol="0" anchor="ctr"/>
           <a:lstStyle/>
           <a:p>
-            <a:pPr indent="0" marL="0">
+            <a:pPr marL="0" indent="0">
               <a:buNone/>
             </a:pPr>
             <a:r>
@@ -5239,7 +4973,7 @@
           <a:bodyPr wrap="square" rtlCol="0" anchor="ctr"/>
           <a:lstStyle/>
           <a:p>
-            <a:pPr indent="0" marL="0">
+            <a:pPr marL="0" indent="0">
               <a:buNone/>
             </a:pPr>
             <a:r>
@@ -5298,7 +5032,7 @@
           <a:bodyPr wrap="square" rtlCol="0" anchor="ctr"/>
           <a:lstStyle/>
           <a:p>
-            <a:pPr indent="0" marL="0">
+            <a:pPr marL="0" indent="0">
               <a:buNone/>
             </a:pPr>
             <a:r>
@@ -5337,7 +5071,7 @@
           <a:bodyPr wrap="square" rtlCol="0" anchor="ctr"/>
           <a:lstStyle/>
           <a:p>
-            <a:pPr indent="0" marL="0">
+            <a:pPr marL="0" indent="0">
               <a:buNone/>
             </a:pPr>
             <a:r>
@@ -5376,7 +5110,7 @@
           <a:bodyPr wrap="square" rtlCol="0" anchor="ctr"/>
           <a:lstStyle/>
           <a:p>
-            <a:pPr algn="r" indent="0" marL="0">
+            <a:pPr marL="0" indent="0" algn="r">
               <a:buNone/>
             </a:pPr>
             <a:r>
@@ -5460,11 +5194,11 @@
           <a:bodyPr wrap="square" rtlCol="0" anchor="ctr"/>
           <a:lstStyle/>
           <a:p>
-            <a:pPr indent="0" marL="0">
-              <a:buNone/>
-            </a:pPr>
-            <a:r>
-              <a:rPr lang="en-US" sz="1000" spc="400" kern="0" dirty="0">
+            <a:pPr marL="0" indent="0">
+              <a:buNone/>
+            </a:pPr>
+            <a:r>
+              <a:rPr lang="en-US" sz="1000" kern="0" spc="400" dirty="0">
                 <a:solidFill>
                   <a:srgbClr val="4CAF50"/>
                 </a:solidFill>
@@ -5499,7 +5233,7 @@
           <a:bodyPr wrap="square" rtlCol="0" anchor="ctr"/>
           <a:lstStyle/>
           <a:p>
-            <a:pPr indent="0" marL="0">
+            <a:pPr marL="0" indent="0">
               <a:buNone/>
             </a:pPr>
             <a:r>
@@ -5563,7 +5297,7 @@
           <a:bodyPr wrap="square" rtlCol="0" anchor="ctr"/>
           <a:lstStyle/>
           <a:p>
-            <a:pPr indent="0" marL="0">
+            <a:pPr marL="0" indent="0">
               <a:buNone/>
             </a:pPr>
             <a:r>
@@ -5602,7 +5336,7 @@
           <a:bodyPr wrap="square" rtlCol="0" anchor="ctr"/>
           <a:lstStyle/>
           <a:p>
-            <a:pPr indent="0" marL="0">
+            <a:pPr marL="0" indent="0">
               <a:buNone/>
             </a:pPr>
             <a:r>
@@ -5641,7 +5375,7 @@
           <a:bodyPr wrap="square" rtlCol="0" anchor="ctr"/>
           <a:lstStyle/>
           <a:p>
-            <a:pPr indent="0" marL="0">
+            <a:pPr marL="0" indent="0">
               <a:buNone/>
             </a:pPr>
             <a:r>
@@ -5680,7 +5414,7 @@
           <a:bodyPr wrap="square" rtlCol="0" anchor="ctr"/>
           <a:lstStyle/>
           <a:p>
-            <a:pPr algn="ctr" indent="0" marL="0">
+            <a:pPr marL="0" indent="0" algn="ctr">
               <a:buNone/>
             </a:pPr>
             <a:r>
@@ -5744,7 +5478,7 @@
           <a:bodyPr wrap="square" rtlCol="0" anchor="ctr"/>
           <a:lstStyle/>
           <a:p>
-            <a:pPr indent="0" marL="0">
+            <a:pPr marL="0" indent="0">
               <a:buNone/>
             </a:pPr>
             <a:r>
@@ -5783,7 +5517,7 @@
           <a:bodyPr wrap="square" rtlCol="0" anchor="ctr"/>
           <a:lstStyle/>
           <a:p>
-            <a:pPr indent="0" marL="0">
+            <a:pPr marL="0" indent="0">
               <a:buNone/>
             </a:pPr>
             <a:r>
@@ -5822,7 +5556,7 @@
           <a:bodyPr wrap="square" rtlCol="0" anchor="ctr"/>
           <a:lstStyle/>
           <a:p>
-            <a:pPr indent="0" marL="0">
+            <a:pPr marL="0" indent="0">
               <a:buNone/>
             </a:pPr>
             <a:r>
@@ -5861,7 +5595,7 @@
           <a:bodyPr wrap="square" rtlCol="0" anchor="ctr"/>
           <a:lstStyle/>
           <a:p>
-            <a:pPr algn="ctr" indent="0" marL="0">
+            <a:pPr marL="0" indent="0" algn="ctr">
               <a:buNone/>
             </a:pPr>
             <a:r>
@@ -5925,7 +5659,7 @@
           <a:bodyPr wrap="square" rtlCol="0" anchor="ctr"/>
           <a:lstStyle/>
           <a:p>
-            <a:pPr indent="0" marL="0">
+            <a:pPr marL="0" indent="0">
               <a:buNone/>
             </a:pPr>
             <a:r>
@@ -5964,7 +5698,7 @@
           <a:bodyPr wrap="square" rtlCol="0" anchor="ctr"/>
           <a:lstStyle/>
           <a:p>
-            <a:pPr indent="0" marL="0">
+            <a:pPr marL="0" indent="0">
               <a:buNone/>
             </a:pPr>
             <a:r>
@@ -6003,7 +5737,7 @@
           <a:bodyPr wrap="square" rtlCol="0" anchor="ctr"/>
           <a:lstStyle/>
           <a:p>
-            <a:pPr indent="0" marL="0">
+            <a:pPr marL="0" indent="0">
               <a:buNone/>
             </a:pPr>
             <a:r>
@@ -6042,7 +5776,7 @@
           <a:bodyPr wrap="square" rtlCol="0" anchor="ctr"/>
           <a:lstStyle/>
           <a:p>
-            <a:pPr algn="ctr" indent="0" marL="0">
+            <a:pPr marL="0" indent="0" algn="ctr">
               <a:buNone/>
             </a:pPr>
             <a:r>
@@ -6081,7 +5815,7 @@
           <a:bodyPr wrap="square" rtlCol="0" anchor="ctr"/>
           <a:lstStyle/>
           <a:p>
-            <a:pPr algn="r" indent="0" marL="0">
+            <a:pPr marL="0" indent="0" algn="r">
               <a:buNone/>
             </a:pPr>
             <a:r>
@@ -6165,11 +5899,11 @@
           <a:bodyPr wrap="square" rtlCol="0" anchor="ctr"/>
           <a:lstStyle/>
           <a:p>
-            <a:pPr indent="0" marL="0">
-              <a:buNone/>
-            </a:pPr>
-            <a:r>
-              <a:rPr lang="en-US" sz="1000" spc="400" kern="0" dirty="0">
+            <a:pPr marL="0" indent="0">
+              <a:buNone/>
+            </a:pPr>
+            <a:r>
+              <a:rPr lang="en-US" sz="1000" kern="0" spc="400" dirty="0">
                 <a:solidFill>
                   <a:srgbClr val="4CAF50"/>
                 </a:solidFill>
@@ -6204,7 +5938,7 @@
           <a:bodyPr wrap="square" rtlCol="0" anchor="ctr"/>
           <a:lstStyle/>
           <a:p>
-            <a:pPr indent="0" marL="0">
+            <a:pPr marL="0" indent="0">
               <a:buNone/>
             </a:pPr>
             <a:r>
@@ -6263,7 +5997,7 @@
           <a:bodyPr wrap="square" rtlCol="0" anchor="ctr"/>
           <a:lstStyle/>
           <a:p>
-            <a:pPr indent="0" marL="0">
+            <a:pPr marL="0" indent="0">
               <a:buNone/>
             </a:pPr>
             <a:r>
@@ -6322,7 +6056,7 @@
           <a:bodyPr wrap="square" rtlCol="0" anchor="ctr"/>
           <a:lstStyle/>
           <a:p>
-            <a:pPr indent="0" marL="0">
+            <a:pPr marL="0" indent="0">
               <a:buNone/>
             </a:pPr>
             <a:r>
@@ -6381,7 +6115,7 @@
           <a:bodyPr wrap="square" rtlCol="0" anchor="ctr"/>
           <a:lstStyle/>
           <a:p>
-            <a:pPr indent="0" marL="0">
+            <a:pPr marL="0" indent="0">
               <a:buNone/>
             </a:pPr>
             <a:r>
@@ -6440,7 +6174,7 @@
           <a:bodyPr wrap="square" rtlCol="0" anchor="ctr"/>
           <a:lstStyle/>
           <a:p>
-            <a:pPr indent="0" marL="0">
+            <a:pPr marL="0" indent="0">
               <a:buNone/>
             </a:pPr>
             <a:r>
@@ -6479,7 +6213,7 @@
           <a:bodyPr wrap="square" rtlCol="0" anchor="ctr"/>
           <a:lstStyle/>
           <a:p>
-            <a:pPr algn="ctr" indent="0" marL="0">
+            <a:pPr marL="0" indent="0" algn="ctr">
               <a:buNone/>
             </a:pPr>
             <a:r>
@@ -6518,7 +6252,7 @@
           <a:bodyPr wrap="square" rtlCol="0" anchor="ctr"/>
           <a:lstStyle/>
           <a:p>
-            <a:pPr algn="r" indent="0" marL="0">
+            <a:pPr marL="0" indent="0" algn="r">
               <a:buNone/>
             </a:pPr>
             <a:r>
@@ -6602,11 +6336,11 @@
           <a:bodyPr wrap="square" rtlCol="0" anchor="ctr"/>
           <a:lstStyle/>
           <a:p>
-            <a:pPr indent="0" marL="0">
-              <a:buNone/>
-            </a:pPr>
-            <a:r>
-              <a:rPr lang="en-US" sz="1000" spc="400" kern="0" dirty="0">
+            <a:pPr marL="0" indent="0">
+              <a:buNone/>
+            </a:pPr>
+            <a:r>
+              <a:rPr lang="en-US" sz="1000" kern="0" spc="400" dirty="0">
                 <a:solidFill>
                   <a:srgbClr val="4CAF50"/>
                 </a:solidFill>
@@ -6641,7 +6375,7 @@
           <a:bodyPr wrap="square" rtlCol="0" anchor="ctr"/>
           <a:lstStyle/>
           <a:p>
-            <a:pPr indent="0" marL="0">
+            <a:pPr marL="0" indent="0">
               <a:buNone/>
             </a:pPr>
             <a:r>
@@ -6703,7 +6437,7 @@
           <a:bodyPr wrap="square" rtlCol="0" anchor="ctr"/>
           <a:lstStyle/>
           <a:p>
-            <a:pPr indent="0" marL="0">
+            <a:pPr marL="0" indent="0">
               <a:buNone/>
             </a:pPr>
             <a:r>
@@ -6742,7 +6476,7 @@
           <a:bodyPr wrap="square" rtlCol="0" anchor="ctr"/>
           <a:lstStyle/>
           <a:p>
-            <a:pPr indent="0" marL="0">
+            <a:pPr marL="0" indent="0">
               <a:buNone/>
             </a:pPr>
             <a:r>
@@ -6781,7 +6515,7 @@
           <a:bodyPr wrap="square" rtlCol="0" anchor="ctr"/>
           <a:lstStyle/>
           <a:p>
-            <a:pPr indent="0" marL="0">
+            <a:pPr marL="0" indent="0">
               <a:buNone/>
             </a:pPr>
             <a:r>
@@ -6820,7 +6554,7 @@
           <a:bodyPr wrap="square" rtlCol="0" anchor="ctr"/>
           <a:lstStyle/>
           <a:p>
-            <a:pPr indent="0" marL="0">
+            <a:pPr marL="0" indent="0">
               <a:buNone/>
             </a:pPr>
             <a:r>
@@ -6859,7 +6593,7 @@
           <a:bodyPr wrap="square" rtlCol="0" anchor="ctr"/>
           <a:lstStyle/>
           <a:p>
-            <a:pPr indent="0" marL="0">
+            <a:pPr marL="0" indent="0">
               <a:buNone/>
             </a:pPr>
             <a:r>
@@ -6898,7 +6632,7 @@
           <a:bodyPr wrap="square" rtlCol="0" anchor="ctr"/>
           <a:lstStyle/>
           <a:p>
-            <a:pPr indent="0" marL="0">
+            <a:pPr marL="0" indent="0">
               <a:buNone/>
             </a:pPr>
             <a:r>
@@ -6937,7 +6671,7 @@
           <a:bodyPr wrap="square" rtlCol="0" anchor="ctr"/>
           <a:lstStyle/>
           <a:p>
-            <a:pPr indent="0" marL="0">
+            <a:pPr marL="0" indent="0">
               <a:buNone/>
             </a:pPr>
             <a:r>
@@ -6976,7 +6710,7 @@
           <a:bodyPr wrap="square" rtlCol="0" anchor="ctr"/>
           <a:lstStyle/>
           <a:p>
-            <a:pPr indent="0" marL="0">
+            <a:pPr marL="0" indent="0">
               <a:buNone/>
             </a:pPr>
             <a:r>
@@ -7015,7 +6749,7 @@
           <a:bodyPr wrap="square" rtlCol="0" anchor="ctr"/>
           <a:lstStyle/>
           <a:p>
-            <a:pPr indent="0" marL="0">
+            <a:pPr marL="0" indent="0">
               <a:buNone/>
             </a:pPr>
             <a:r>
@@ -7054,7 +6788,7 @@
           <a:bodyPr wrap="square" rtlCol="0" anchor="ctr"/>
           <a:lstStyle/>
           <a:p>
-            <a:pPr indent="0" marL="0">
+            <a:pPr marL="0" indent="0">
               <a:buNone/>
             </a:pPr>
             <a:r>
@@ -7093,7 +6827,7 @@
           <a:bodyPr wrap="square" rtlCol="0" anchor="ctr"/>
           <a:lstStyle/>
           <a:p>
-            <a:pPr indent="0" marL="0">
+            <a:pPr marL="0" indent="0">
               <a:buNone/>
             </a:pPr>
             <a:r>
@@ -7132,7 +6866,7 @@
           <a:bodyPr wrap="square" rtlCol="0" anchor="ctr"/>
           <a:lstStyle/>
           <a:p>
-            <a:pPr indent="0" marL="0">
+            <a:pPr marL="0" indent="0">
               <a:buNone/>
             </a:pPr>
             <a:r>
@@ -7171,7 +6905,7 @@
           <a:bodyPr wrap="square" rtlCol="0" anchor="ctr"/>
           <a:lstStyle/>
           <a:p>
-            <a:pPr algn="r" indent="0" marL="0">
+            <a:pPr marL="0" indent="0" algn="r">
               <a:buNone/>
             </a:pPr>
             <a:r>
@@ -7255,11 +6989,11 @@
           <a:bodyPr wrap="square" rtlCol="0" anchor="ctr"/>
           <a:lstStyle/>
           <a:p>
-            <a:pPr indent="0" marL="0">
-              <a:buNone/>
-            </a:pPr>
-            <a:r>
-              <a:rPr lang="en-US" sz="1000" spc="400" kern="0" dirty="0">
+            <a:pPr marL="0" indent="0">
+              <a:buNone/>
+            </a:pPr>
+            <a:r>
+              <a:rPr lang="en-US" sz="1000" kern="0" spc="400" dirty="0">
                 <a:solidFill>
                   <a:srgbClr val="4CAF50"/>
                 </a:solidFill>
@@ -7294,7 +7028,7 @@
           <a:bodyPr wrap="square" rtlCol="0" anchor="ctr"/>
           <a:lstStyle/>
           <a:p>
-            <a:pPr indent="0" marL="0">
+            <a:pPr marL="0" indent="0">
               <a:buNone/>
             </a:pPr>
             <a:r>
@@ -7358,7 +7092,7 @@
           <a:bodyPr wrap="square" rtlCol="0" anchor="ctr"/>
           <a:lstStyle/>
           <a:p>
-            <a:pPr algn="ctr" indent="0" marL="0">
+            <a:pPr marL="0" indent="0" algn="ctr">
               <a:buNone/>
             </a:pPr>
             <a:r>
@@ -7422,7 +7156,7 @@
           <a:bodyPr wrap="square" rtlCol="0" anchor="ctr"/>
           <a:lstStyle/>
           <a:p>
-            <a:pPr algn="ctr" indent="0" marL="0">
+            <a:pPr marL="0" indent="0" algn="ctr">
               <a:buNone/>
             </a:pPr>
             <a:r>
@@ -7486,7 +7220,7 @@
           <a:bodyPr wrap="square" rtlCol="0" anchor="ctr"/>
           <a:lstStyle/>
           <a:p>
-            <a:pPr algn="ctr" indent="0" marL="0">
+            <a:pPr marL="0" indent="0" algn="ctr">
               <a:buNone/>
             </a:pPr>
             <a:r>
@@ -7550,7 +7284,7 @@
           <a:bodyPr wrap="square" rtlCol="0" anchor="ctr"/>
           <a:lstStyle/>
           <a:p>
-            <a:pPr algn="ctr" indent="0" marL="0">
+            <a:pPr marL="0" indent="0" algn="ctr">
               <a:buNone/>
             </a:pPr>
             <a:r>
@@ -7614,7 +7348,7 @@
           <a:bodyPr wrap="square" rtlCol="0" anchor="ctr"/>
           <a:lstStyle/>
           <a:p>
-            <a:pPr algn="ctr" indent="0" marL="0">
+            <a:pPr marL="0" indent="0" algn="ctr">
               <a:buNone/>
             </a:pPr>
             <a:r>
@@ -7678,7 +7412,7 @@
           <a:bodyPr wrap="square" rtlCol="0" anchor="ctr"/>
           <a:lstStyle/>
           <a:p>
-            <a:pPr algn="ctr" indent="0" marL="0">
+            <a:pPr marL="0" indent="0" algn="ctr">
               <a:buNone/>
             </a:pPr>
             <a:r>
@@ -7742,7 +7476,7 @@
           <a:bodyPr wrap="square" rtlCol="0" anchor="ctr"/>
           <a:lstStyle/>
           <a:p>
-            <a:pPr algn="ctr" indent="0" marL="0">
+            <a:pPr marL="0" indent="0" algn="ctr">
               <a:buNone/>
             </a:pPr>
             <a:r>
@@ -7806,7 +7540,7 @@
           <a:bodyPr wrap="square" rtlCol="0" anchor="ctr"/>
           <a:lstStyle/>
           <a:p>
-            <a:pPr algn="ctr" indent="0" marL="0">
+            <a:pPr marL="0" indent="0" algn="ctr">
               <a:buNone/>
             </a:pPr>
             <a:r>
@@ -7870,7 +7604,7 @@
           <a:bodyPr wrap="square" rtlCol="0" anchor="ctr"/>
           <a:lstStyle/>
           <a:p>
-            <a:pPr algn="ctr" indent="0" marL="0">
+            <a:pPr marL="0" indent="0" algn="ctr">
               <a:buNone/>
             </a:pPr>
             <a:r>
@@ -7934,7 +7668,7 @@
           <a:bodyPr wrap="square" rtlCol="0" anchor="ctr"/>
           <a:lstStyle/>
           <a:p>
-            <a:pPr algn="ctr" indent="0" marL="0">
+            <a:pPr marL="0" indent="0" algn="ctr">
               <a:buNone/>
             </a:pPr>
             <a:r>
@@ -7998,7 +7732,7 @@
           <a:bodyPr wrap="square" rtlCol="0" anchor="ctr"/>
           <a:lstStyle/>
           <a:p>
-            <a:pPr algn="ctr" indent="0" marL="0">
+            <a:pPr marL="0" indent="0" algn="ctr">
               <a:buNone/>
             </a:pPr>
             <a:r>
@@ -8062,7 +7796,7 @@
           <a:bodyPr wrap="square" rtlCol="0" anchor="ctr"/>
           <a:lstStyle/>
           <a:p>
-            <a:pPr algn="ctr" indent="0" marL="0">
+            <a:pPr marL="0" indent="0" algn="ctr">
               <a:buNone/>
             </a:pPr>
             <a:r>
@@ -8126,7 +7860,7 @@
           <a:bodyPr wrap="square" rtlCol="0" anchor="ctr"/>
           <a:lstStyle/>
           <a:p>
-            <a:pPr algn="ctr" indent="0" marL="0">
+            <a:pPr marL="0" indent="0" algn="ctr">
               <a:buNone/>
             </a:pPr>
             <a:r>
@@ -8190,7 +7924,7 @@
           <a:bodyPr wrap="square" rtlCol="0" anchor="ctr"/>
           <a:lstStyle/>
           <a:p>
-            <a:pPr algn="ctr" indent="0" marL="0">
+            <a:pPr marL="0" indent="0" algn="ctr">
               <a:buNone/>
             </a:pPr>
             <a:r>
@@ -8229,7 +7963,7 @@
           <a:bodyPr wrap="square" rtlCol="0" anchor="ctr"/>
           <a:lstStyle/>
           <a:p>
-            <a:pPr algn="r" indent="0" marL="0">
+            <a:pPr marL="0" indent="0" algn="r">
               <a:buNone/>
             </a:pPr>
             <a:r>
@@ -8313,11 +8047,11 @@
           <a:bodyPr wrap="square" rtlCol="0" anchor="ctr"/>
           <a:lstStyle/>
           <a:p>
-            <a:pPr indent="0" marL="0">
-              <a:buNone/>
-            </a:pPr>
-            <a:r>
-              <a:rPr lang="en-US" sz="1000" spc="400" kern="0" dirty="0">
+            <a:pPr marL="0" indent="0">
+              <a:buNone/>
+            </a:pPr>
+            <a:r>
+              <a:rPr lang="en-US" sz="1000" kern="0" spc="400" dirty="0">
                 <a:solidFill>
                   <a:srgbClr val="4CAF50"/>
                 </a:solidFill>
@@ -8352,7 +8086,7 @@
           <a:bodyPr wrap="square" rtlCol="0" anchor="ctr"/>
           <a:lstStyle/>
           <a:p>
-            <a:pPr indent="0" marL="0">
+            <a:pPr marL="0" indent="0">
               <a:buNone/>
             </a:pPr>
             <a:r>
@@ -8391,7 +8125,7 @@
           <a:bodyPr wrap="square" rtlCol="0" anchor="ctr"/>
           <a:lstStyle/>
           <a:p>
-            <a:pPr indent="0" marL="0">
+            <a:pPr marL="0" indent="0">
               <a:buNone/>
             </a:pPr>
             <a:r>
@@ -8430,7 +8164,7 @@
           <a:bodyPr wrap="square" rtlCol="0" anchor="ctr"/>
           <a:lstStyle/>
           <a:p>
-            <a:pPr algn="r" indent="0" marL="0">
+            <a:pPr marL="0" indent="0" algn="r">
               <a:buNone/>
             </a:pPr>
             <a:r>
@@ -8492,7 +8226,7 @@
           <a:bodyPr wrap="square" rtlCol="0" anchor="ctr"/>
           <a:lstStyle/>
           <a:p>
-            <a:pPr indent="0" marL="0">
+            <a:pPr marL="0" indent="0">
               <a:buNone/>
             </a:pPr>
             <a:r>
@@ -8531,7 +8265,7 @@
           <a:bodyPr wrap="square" rtlCol="0" anchor="ctr"/>
           <a:lstStyle/>
           <a:p>
-            <a:pPr algn="r" indent="0" marL="0">
+            <a:pPr marL="0" indent="0" algn="r">
               <a:buNone/>
             </a:pPr>
             <a:r>
@@ -8593,7 +8327,7 @@
           <a:bodyPr wrap="square" rtlCol="0" anchor="ctr"/>
           <a:lstStyle/>
           <a:p>
-            <a:pPr indent="0" marL="0">
+            <a:pPr marL="0" indent="0">
               <a:buNone/>
             </a:pPr>
             <a:r>
@@ -8632,7 +8366,7 @@
           <a:bodyPr wrap="square" rtlCol="0" anchor="ctr"/>
           <a:lstStyle/>
           <a:p>
-            <a:pPr algn="r" indent="0" marL="0">
+            <a:pPr marL="0" indent="0" algn="r">
               <a:buNone/>
             </a:pPr>
             <a:r>
@@ -8694,7 +8428,7 @@
           <a:bodyPr wrap="square" rtlCol="0" anchor="ctr"/>
           <a:lstStyle/>
           <a:p>
-            <a:pPr indent="0" marL="0">
+            <a:pPr marL="0" indent="0">
               <a:buNone/>
             </a:pPr>
             <a:r>
@@ -8733,7 +8467,7 @@
           <a:bodyPr wrap="square" rtlCol="0" anchor="ctr"/>
           <a:lstStyle/>
           <a:p>
-            <a:pPr algn="r" indent="0" marL="0">
+            <a:pPr marL="0" indent="0" algn="r">
               <a:buNone/>
             </a:pPr>
             <a:r>
@@ -8795,7 +8529,7 @@
           <a:bodyPr wrap="square" rtlCol="0" anchor="ctr"/>
           <a:lstStyle/>
           <a:p>
-            <a:pPr indent="0" marL="0">
+            <a:pPr marL="0" indent="0">
               <a:buNone/>
             </a:pPr>
             <a:r>
@@ -8834,7 +8568,7 @@
           <a:bodyPr wrap="square" rtlCol="0" anchor="ctr"/>
           <a:lstStyle/>
           <a:p>
-            <a:pPr algn="r" indent="0" marL="0">
+            <a:pPr marL="0" indent="0" algn="r">
               <a:buNone/>
             </a:pPr>
             <a:r>
@@ -8896,7 +8630,7 @@
           <a:bodyPr wrap="square" rtlCol="0" anchor="ctr"/>
           <a:lstStyle/>
           <a:p>
-            <a:pPr indent="0" marL="0">
+            <a:pPr marL="0" indent="0">
               <a:buNone/>
             </a:pPr>
             <a:r>
@@ -8935,7 +8669,7 @@
           <a:bodyPr wrap="square" rtlCol="0" anchor="ctr"/>
           <a:lstStyle/>
           <a:p>
-            <a:pPr algn="r" indent="0" marL="0">
+            <a:pPr marL="0" indent="0" algn="r">
               <a:buNone/>
             </a:pPr>
             <a:r>
@@ -8997,7 +8731,7 @@
           <a:bodyPr wrap="square" rtlCol="0" anchor="ctr"/>
           <a:lstStyle/>
           <a:p>
-            <a:pPr indent="0" marL="0">
+            <a:pPr marL="0" indent="0">
               <a:buNone/>
             </a:pPr>
             <a:r>
@@ -9036,7 +8770,7 @@
           <a:bodyPr wrap="square" rtlCol="0" anchor="ctr"/>
           <a:lstStyle/>
           <a:p>
-            <a:pPr algn="r" indent="0" marL="0">
+            <a:pPr marL="0" indent="0" algn="r">
               <a:buNone/>
             </a:pPr>
             <a:r>
@@ -9075,7 +8809,7 @@
           <a:bodyPr wrap="square" rtlCol="0" anchor="ctr"/>
           <a:lstStyle/>
           <a:p>
-            <a:pPr algn="r" indent="0" marL="0">
+            <a:pPr marL="0" indent="0" algn="r">
               <a:buNone/>
             </a:pPr>
             <a:r>
@@ -9159,11 +8893,11 @@
           <a:bodyPr wrap="square" rtlCol="0" anchor="ctr"/>
           <a:lstStyle/>
           <a:p>
-            <a:pPr indent="0" marL="0">
-              <a:buNone/>
-            </a:pPr>
-            <a:r>
-              <a:rPr lang="en-US" sz="1000" spc="400" kern="0" dirty="0">
+            <a:pPr marL="0" indent="0">
+              <a:buNone/>
+            </a:pPr>
+            <a:r>
+              <a:rPr lang="en-US" sz="1000" kern="0" spc="400" dirty="0">
                 <a:solidFill>
                   <a:srgbClr val="4CAF50"/>
                 </a:solidFill>
@@ -9198,7 +8932,7 @@
           <a:bodyPr wrap="square" rtlCol="0" anchor="ctr"/>
           <a:lstStyle/>
           <a:p>
-            <a:pPr indent="0" marL="0">
+            <a:pPr marL="0" indent="0">
               <a:buNone/>
             </a:pPr>
             <a:r>
@@ -9237,7 +8971,7 @@
           <a:bodyPr wrap="square" rtlCol="0" anchor="ctr"/>
           <a:lstStyle/>
           <a:p>
-            <a:pPr algn="ctr" indent="0" marL="0">
+            <a:pPr marL="0" indent="0" algn="ctr">
               <a:buNone/>
             </a:pPr>
             <a:endParaRPr lang="en-US" sz="1000" dirty="0"/>
@@ -9265,7 +8999,7 @@
           <a:bodyPr wrap="square" rtlCol="0" anchor="ctr"/>
           <a:lstStyle/>
           <a:p>
-            <a:pPr algn="ctr" indent="0" marL="0">
+            <a:pPr marL="0" indent="0" algn="ctr">
               <a:buNone/>
             </a:pPr>
             <a:r>
@@ -9304,7 +9038,7 @@
           <a:bodyPr wrap="square" rtlCol="0" anchor="ctr"/>
           <a:lstStyle/>
           <a:p>
-            <a:pPr algn="ctr" indent="0" marL="0">
+            <a:pPr marL="0" indent="0" algn="ctr">
               <a:buNone/>
             </a:pPr>
             <a:r>
@@ -9343,7 +9077,7 @@
           <a:bodyPr wrap="square" rtlCol="0" anchor="ctr"/>
           <a:lstStyle/>
           <a:p>
-            <a:pPr algn="ctr" indent="0" marL="0">
+            <a:pPr marL="0" indent="0" algn="ctr">
               <a:buNone/>
             </a:pPr>
             <a:r>
@@ -9382,7 +9116,7 @@
           <a:bodyPr wrap="square" rtlCol="0" anchor="ctr"/>
           <a:lstStyle/>
           <a:p>
-            <a:pPr algn="ctr" indent="0" marL="0">
+            <a:pPr marL="0" indent="0" algn="ctr">
               <a:buNone/>
             </a:pPr>
             <a:r>
@@ -9421,7 +9155,7 @@
           <a:bodyPr wrap="square" rtlCol="0" anchor="ctr"/>
           <a:lstStyle/>
           <a:p>
-            <a:pPr algn="ctr" indent="0" marL="0">
+            <a:pPr marL="0" indent="0" algn="ctr">
               <a:buNone/>
             </a:pPr>
             <a:r>
@@ -9460,7 +9194,7 @@
           <a:bodyPr wrap="square" rtlCol="0" anchor="ctr"/>
           <a:lstStyle/>
           <a:p>
-            <a:pPr algn="ctr" indent="0" marL="0">
+            <a:pPr marL="0" indent="0" algn="ctr">
               <a:buNone/>
             </a:pPr>
             <a:r>
@@ -9499,7 +9233,7 @@
           <a:bodyPr wrap="square" rtlCol="0" anchor="ctr"/>
           <a:lstStyle/>
           <a:p>
-            <a:pPr algn="ctr" indent="0" marL="0">
+            <a:pPr marL="0" indent="0" algn="ctr">
               <a:buNone/>
             </a:pPr>
             <a:r>
@@ -9538,7 +9272,7 @@
           <a:bodyPr wrap="square" rtlCol="0" anchor="ctr"/>
           <a:lstStyle/>
           <a:p>
-            <a:pPr algn="ctr" indent="0" marL="0">
+            <a:pPr marL="0" indent="0" algn="ctr">
               <a:buNone/>
             </a:pPr>
             <a:r>
@@ -9577,7 +9311,7 @@
           <a:bodyPr wrap="square" rtlCol="0" anchor="ctr"/>
           <a:lstStyle/>
           <a:p>
-            <a:pPr algn="ctr" indent="0" marL="0">
+            <a:pPr marL="0" indent="0" algn="ctr">
               <a:buNone/>
             </a:pPr>
             <a:r>
@@ -9616,7 +9350,7 @@
           <a:bodyPr wrap="square" rtlCol="0" anchor="ctr"/>
           <a:lstStyle/>
           <a:p>
-            <a:pPr algn="ctr" indent="0" marL="0">
+            <a:pPr marL="0" indent="0" algn="ctr">
               <a:buNone/>
             </a:pPr>
             <a:r>
@@ -9655,7 +9389,7 @@
           <a:bodyPr wrap="square" rtlCol="0" anchor="ctr"/>
           <a:lstStyle/>
           <a:p>
-            <a:pPr algn="ctr" indent="0" marL="0">
+            <a:pPr marL="0" indent="0" algn="ctr">
               <a:buNone/>
             </a:pPr>
             <a:r>
@@ -9694,7 +9428,7 @@
           <a:bodyPr wrap="square" rtlCol="0" anchor="ctr"/>
           <a:lstStyle/>
           <a:p>
-            <a:pPr algn="ctr" indent="0" marL="0">
+            <a:pPr marL="0" indent="0" algn="ctr">
               <a:buNone/>
             </a:pPr>
             <a:r>
@@ -9733,7 +9467,7 @@
           <a:bodyPr wrap="square" rtlCol="0" anchor="ctr"/>
           <a:lstStyle/>
           <a:p>
-            <a:pPr algn="ctr" indent="0" marL="0">
+            <a:pPr marL="0" indent="0" algn="ctr">
               <a:buNone/>
             </a:pPr>
             <a:r>
@@ -9772,7 +9506,7 @@
           <a:bodyPr wrap="square" rtlCol="0" anchor="ctr"/>
           <a:lstStyle/>
           <a:p>
-            <a:pPr algn="ctr" indent="0" marL="0">
+            <a:pPr marL="0" indent="0" algn="ctr">
               <a:buNone/>
             </a:pPr>
             <a:r>
@@ -9811,7 +9545,7 @@
           <a:bodyPr wrap="square" rtlCol="0" anchor="ctr"/>
           <a:lstStyle/>
           <a:p>
-            <a:pPr algn="ctr" indent="0" marL="0">
+            <a:pPr marL="0" indent="0" algn="ctr">
               <a:buNone/>
             </a:pPr>
             <a:r>
@@ -9850,7 +9584,7 @@
           <a:bodyPr wrap="square" rtlCol="0" anchor="ctr"/>
           <a:lstStyle/>
           <a:p>
-            <a:pPr algn="ctr" indent="0" marL="0">
+            <a:pPr marL="0" indent="0" algn="ctr">
               <a:buNone/>
             </a:pPr>
             <a:r>
@@ -9889,7 +9623,7 @@
           <a:bodyPr wrap="square" rtlCol="0" anchor="ctr"/>
           <a:lstStyle/>
           <a:p>
-            <a:pPr algn="ctr" indent="0" marL="0">
+            <a:pPr marL="0" indent="0" algn="ctr">
               <a:buNone/>
             </a:pPr>
             <a:r>
@@ -9928,7 +9662,7 @@
           <a:bodyPr wrap="square" rtlCol="0" anchor="ctr"/>
           <a:lstStyle/>
           <a:p>
-            <a:pPr algn="ctr" indent="0" marL="0">
+            <a:pPr marL="0" indent="0" algn="ctr">
               <a:buNone/>
             </a:pPr>
             <a:r>
@@ -9967,7 +9701,7 @@
           <a:bodyPr wrap="square" rtlCol="0" anchor="ctr"/>
           <a:lstStyle/>
           <a:p>
-            <a:pPr algn="ctr" indent="0" marL="0">
+            <a:pPr marL="0" indent="0" algn="ctr">
               <a:buNone/>
             </a:pPr>
             <a:r>
@@ -10006,7 +9740,7 @@
           <a:bodyPr wrap="square" rtlCol="0" anchor="ctr"/>
           <a:lstStyle/>
           <a:p>
-            <a:pPr algn="ctr" indent="0" marL="0">
+            <a:pPr marL="0" indent="0" algn="ctr">
               <a:buNone/>
             </a:pPr>
             <a:r>
@@ -10045,7 +9779,7 @@
           <a:bodyPr wrap="square" rtlCol="0" anchor="ctr"/>
           <a:lstStyle/>
           <a:p>
-            <a:pPr algn="r" indent="0" marL="0">
+            <a:pPr marL="0" indent="0" algn="r">
               <a:buNone/>
             </a:pPr>
             <a:r>
@@ -10364,4 +10098,319 @@
     </a:ext>
   </a:extLst>
 </a:theme>
+</file>
+
+<file path=ppt/theme/theme2.xml><?xml version="1.0" encoding="utf-8"?>
+<a:theme xmlns:a="http://schemas.openxmlformats.org/drawingml/2006/main" name="Office 主题​​">
+  <a:themeElements>
+    <a:clrScheme name="Office">
+      <a:dk1>
+        <a:sysClr val="windowText" lastClr="000000"/>
+      </a:dk1>
+      <a:lt1>
+        <a:sysClr val="window" lastClr="FFFFFF"/>
+      </a:lt1>
+      <a:dk2>
+        <a:srgbClr val="0E2841"/>
+      </a:dk2>
+      <a:lt2>
+        <a:srgbClr val="E8E8E8"/>
+      </a:lt2>
+      <a:accent1>
+        <a:srgbClr val="156082"/>
+      </a:accent1>
+      <a:accent2>
+        <a:srgbClr val="E97132"/>
+      </a:accent2>
+      <a:accent3>
+        <a:srgbClr val="196B24"/>
+      </a:accent3>
+      <a:accent4>
+        <a:srgbClr val="0F9ED5"/>
+      </a:accent4>
+      <a:accent5>
+        <a:srgbClr val="A02B93"/>
+      </a:accent5>
+      <a:accent6>
+        <a:srgbClr val="4EA72E"/>
+      </a:accent6>
+      <a:hlink>
+        <a:srgbClr val="467886"/>
+      </a:hlink>
+      <a:folHlink>
+        <a:srgbClr val="96607D"/>
+      </a:folHlink>
+    </a:clrScheme>
+    <a:fontScheme name="Office">
+      <a:majorFont>
+        <a:latin typeface="等线 Light" panose="02110004020202020204"/>
+        <a:ea typeface=""/>
+        <a:cs typeface=""/>
+        <a:font script="Jpan" typeface="游ゴシック Light"/>
+        <a:font script="Hang" typeface="맑은 고딕"/>
+        <a:font script="Hans" typeface="等线 Light"/>
+        <a:font script="Hant" typeface="新細明體"/>
+        <a:font script="Arab" typeface="Times New Roman"/>
+        <a:font script="Hebr" typeface="Times New Roman"/>
+        <a:font script="Thai" typeface="Angsana New"/>
+        <a:font script="Ethi" typeface="Nyala"/>
+        <a:font script="Beng" typeface="Vrinda"/>
+        <a:font script="Gujr" typeface="Shruti"/>
+        <a:font script="Khmr" typeface="MoolBoran"/>
+        <a:font script="Knda" typeface="Tunga"/>
+        <a:font script="Guru" typeface="Raavi"/>
+        <a:font script="Cans" typeface="Euphemia"/>
+        <a:font script="Cher" typeface="Plantagenet Cherokee"/>
+        <a:font script="Yiii" typeface="Microsoft Yi Baiti"/>
+        <a:font script="Tibt" typeface="Microsoft Himalaya"/>
+        <a:font script="Thaa" typeface="MV Boli"/>
+        <a:font script="Deva" typeface="Mangal"/>
+        <a:font script="Telu" typeface="Gautami"/>
+        <a:font script="Taml" typeface="Latha"/>
+        <a:font script="Syrc" typeface="Estrangelo Edessa"/>
+        <a:font script="Orya" typeface="Kalinga"/>
+        <a:font script="Mlym" typeface="Kartika"/>
+        <a:font script="Laoo" typeface="DokChampa"/>
+        <a:font script="Sinh" typeface="Iskoola Pota"/>
+        <a:font script="Mong" typeface="Mongolian Baiti"/>
+        <a:font script="Viet" typeface="Times New Roman"/>
+        <a:font script="Uigh" typeface="Microsoft Uighur"/>
+        <a:font script="Geor" typeface="Sylfaen"/>
+        <a:font script="Armn" typeface="Arial"/>
+        <a:font script="Bugi" typeface="Leelawadee UI"/>
+        <a:font script="Bopo" typeface="Microsoft JhengHei"/>
+        <a:font script="Java" typeface="Javanese Text"/>
+        <a:font script="Lisu" typeface="Segoe UI"/>
+        <a:font script="Mymr" typeface="Myanmar Text"/>
+        <a:font script="Nkoo" typeface="Ebrima"/>
+        <a:font script="Olck" typeface="Nirmala UI"/>
+        <a:font script="Osma" typeface="Ebrima"/>
+        <a:font script="Phag" typeface="Phagspa"/>
+        <a:font script="Syrn" typeface="Estrangelo Edessa"/>
+        <a:font script="Syrj" typeface="Estrangelo Edessa"/>
+        <a:font script="Syre" typeface="Estrangelo Edessa"/>
+        <a:font script="Sora" typeface="Nirmala UI"/>
+        <a:font script="Tale" typeface="Microsoft Tai Le"/>
+        <a:font script="Talu" typeface="Microsoft New Tai Lue"/>
+        <a:font script="Tfng" typeface="Ebrima"/>
+      </a:majorFont>
+      <a:minorFont>
+        <a:latin typeface="等线" panose="02110004020202020204"/>
+        <a:ea typeface=""/>
+        <a:cs typeface=""/>
+        <a:font script="Jpan" typeface="游ゴシック"/>
+        <a:font script="Hang" typeface="맑은 고딕"/>
+        <a:font script="Hans" typeface="等线"/>
+        <a:font script="Hant" typeface="新細明體"/>
+        <a:font script="Arab" typeface="Arial"/>
+        <a:font script="Hebr" typeface="Arial"/>
+        <a:font script="Thai" typeface="Cordia New"/>
+        <a:font script="Ethi" typeface="Nyala"/>
+        <a:font script="Beng" typeface="Vrinda"/>
+        <a:font script="Gujr" typeface="Shruti"/>
+        <a:font script="Khmr" typeface="DaunPenh"/>
+        <a:font script="Knda" typeface="Tunga"/>
+        <a:font script="Guru" typeface="Raavi"/>
+        <a:font script="Cans" typeface="Euphemia"/>
+        <a:font script="Cher" typeface="Plantagenet Cherokee"/>
+        <a:font script="Yiii" typeface="Microsoft Yi Baiti"/>
+        <a:font script="Tibt" typeface="Microsoft Himalaya"/>
+        <a:font script="Thaa" typeface="MV Boli"/>
+        <a:font script="Deva" typeface="Mangal"/>
+        <a:font script="Telu" typeface="Gautami"/>
+        <a:font script="Taml" typeface="Latha"/>
+        <a:font script="Syrc" typeface="Estrangelo Edessa"/>
+        <a:font script="Orya" typeface="Kalinga"/>
+        <a:font script="Mlym" typeface="Kartika"/>
+        <a:font script="Laoo" typeface="DokChampa"/>
+        <a:font script="Sinh" typeface="Iskoola Pota"/>
+        <a:font script="Mong" typeface="Mongolian Baiti"/>
+        <a:font script="Viet" typeface="Arial"/>
+        <a:font script="Uigh" typeface="Microsoft Uighur"/>
+        <a:font script="Geor" typeface="Sylfaen"/>
+        <a:font script="Armn" typeface="Arial"/>
+        <a:font script="Bugi" typeface="Leelawadee UI"/>
+        <a:font script="Bopo" typeface="Microsoft JhengHei"/>
+        <a:font script="Java" typeface="Javanese Text"/>
+        <a:font script="Lisu" typeface="Segoe UI"/>
+        <a:font script="Mymr" typeface="Myanmar Text"/>
+        <a:font script="Nkoo" typeface="Ebrima"/>
+        <a:font script="Olck" typeface="Nirmala UI"/>
+        <a:font script="Osma" typeface="Ebrima"/>
+        <a:font script="Phag" typeface="Phagspa"/>
+        <a:font script="Syrn" typeface="Estrangelo Edessa"/>
+        <a:font script="Syrj" typeface="Estrangelo Edessa"/>
+        <a:font script="Syre" typeface="Estrangelo Edessa"/>
+        <a:font script="Sora" typeface="Nirmala UI"/>
+        <a:font script="Tale" typeface="Microsoft Tai Le"/>
+        <a:font script="Talu" typeface="Microsoft New Tai Lue"/>
+        <a:font script="Tfng" typeface="Ebrima"/>
+      </a:minorFont>
+    </a:fontScheme>
+    <a:fmtScheme name="Office">
+      <a:fillStyleLst>
+        <a:solidFill>
+          <a:schemeClr val="phClr"/>
+        </a:solidFill>
+        <a:gradFill rotWithShape="1">
+          <a:gsLst>
+            <a:gs pos="0">
+              <a:schemeClr val="phClr">
+                <a:lumMod val="110000"/>
+                <a:satMod val="105000"/>
+                <a:tint val="67000"/>
+              </a:schemeClr>
+            </a:gs>
+            <a:gs pos="50000">
+              <a:schemeClr val="phClr">
+                <a:lumMod val="105000"/>
+                <a:satMod val="103000"/>
+                <a:tint val="73000"/>
+              </a:schemeClr>
+            </a:gs>
+            <a:gs pos="100000">
+              <a:schemeClr val="phClr">
+                <a:lumMod val="105000"/>
+                <a:satMod val="109000"/>
+                <a:tint val="81000"/>
+              </a:schemeClr>
+            </a:gs>
+          </a:gsLst>
+          <a:lin ang="5400000" scaled="0"/>
+        </a:gradFill>
+        <a:gradFill rotWithShape="1">
+          <a:gsLst>
+            <a:gs pos="0">
+              <a:schemeClr val="phClr">
+                <a:satMod val="103000"/>
+                <a:lumMod val="102000"/>
+                <a:tint val="94000"/>
+              </a:schemeClr>
+            </a:gs>
+            <a:gs pos="50000">
+              <a:schemeClr val="phClr">
+                <a:satMod val="110000"/>
+                <a:lumMod val="100000"/>
+                <a:shade val="100000"/>
+              </a:schemeClr>
+            </a:gs>
+            <a:gs pos="100000">
+              <a:schemeClr val="phClr">
+                <a:lumMod val="99000"/>
+                <a:satMod val="120000"/>
+                <a:shade val="78000"/>
+              </a:schemeClr>
+            </a:gs>
+          </a:gsLst>
+          <a:lin ang="5400000" scaled="0"/>
+        </a:gradFill>
+      </a:fillStyleLst>
+      <a:lnStyleLst>
+        <a:ln w="12700" cap="flat" cmpd="sng" algn="ctr">
+          <a:solidFill>
+            <a:schemeClr val="phClr"/>
+          </a:solidFill>
+          <a:prstDash val="solid"/>
+          <a:miter lim="800000"/>
+        </a:ln>
+        <a:ln w="19050" cap="flat" cmpd="sng" algn="ctr">
+          <a:solidFill>
+            <a:schemeClr val="phClr"/>
+          </a:solidFill>
+          <a:prstDash val="solid"/>
+          <a:miter lim="800000"/>
+        </a:ln>
+        <a:ln w="25400" cap="flat" cmpd="sng" algn="ctr">
+          <a:solidFill>
+            <a:schemeClr val="phClr"/>
+          </a:solidFill>
+          <a:prstDash val="solid"/>
+          <a:miter lim="800000"/>
+        </a:ln>
+      </a:lnStyleLst>
+      <a:effectStyleLst>
+        <a:effectStyle>
+          <a:effectLst/>
+        </a:effectStyle>
+        <a:effectStyle>
+          <a:effectLst/>
+        </a:effectStyle>
+        <a:effectStyle>
+          <a:effectLst>
+            <a:outerShdw blurRad="57150" dist="19050" dir="5400000" algn="ctr" rotWithShape="0">
+              <a:srgbClr val="000000">
+                <a:alpha val="63000"/>
+              </a:srgbClr>
+            </a:outerShdw>
+          </a:effectLst>
+        </a:effectStyle>
+      </a:effectStyleLst>
+      <a:bgFillStyleLst>
+        <a:solidFill>
+          <a:schemeClr val="phClr"/>
+        </a:solidFill>
+        <a:solidFill>
+          <a:schemeClr val="phClr">
+            <a:tint val="95000"/>
+            <a:satMod val="170000"/>
+          </a:schemeClr>
+        </a:solidFill>
+        <a:gradFill rotWithShape="1">
+          <a:gsLst>
+            <a:gs pos="0">
+              <a:schemeClr val="phClr">
+                <a:tint val="93000"/>
+                <a:satMod val="150000"/>
+                <a:shade val="98000"/>
+                <a:lumMod val="102000"/>
+              </a:schemeClr>
+            </a:gs>
+            <a:gs pos="50000">
+              <a:schemeClr val="phClr">
+                <a:tint val="98000"/>
+                <a:satMod val="130000"/>
+                <a:shade val="90000"/>
+                <a:lumMod val="103000"/>
+              </a:schemeClr>
+            </a:gs>
+            <a:gs pos="100000">
+              <a:schemeClr val="phClr">
+                <a:shade val="63000"/>
+                <a:satMod val="120000"/>
+              </a:schemeClr>
+            </a:gs>
+          </a:gsLst>
+          <a:lin ang="5400000" scaled="0"/>
+        </a:gradFill>
+      </a:bgFillStyleLst>
+    </a:fmtScheme>
+  </a:themeElements>
+  <a:objectDefaults>
+    <a:lnDef>
+      <a:spPr/>
+      <a:bodyPr/>
+      <a:lstStyle/>
+      <a:style>
+        <a:lnRef idx="2">
+          <a:schemeClr val="accent1"/>
+        </a:lnRef>
+        <a:fillRef idx="0">
+          <a:schemeClr val="accent1"/>
+        </a:fillRef>
+        <a:effectRef idx="1">
+          <a:schemeClr val="accent1"/>
+        </a:effectRef>
+        <a:fontRef idx="minor">
+          <a:schemeClr val="tx1"/>
+        </a:fontRef>
+      </a:style>
+    </a:lnDef>
+  </a:objectDefaults>
+  <a:extraClrSchemeLst/>
+  <a:extLst>
+    <a:ext uri="{05A4C25C-085E-4340-85A3-A5531E510DB2}">
+      <thm15:themeFamily xmlns:thm15="http://schemas.microsoft.com/office/thememl/2012/main" name="Office Theme" id="{2E142A2C-CD16-42D6-873A-C26D2A0506FA}" vid="{1BDDFF52-6CD6-40A5-AB3C-68EB2F1E4D0A}"/>
+    </a:ext>
+  </a:extLst>
+</a:theme>
 </file>
</xml_diff>

<commit_message>
vault backup: 2026-06-02 12:57:55
</commit_message>
<xml_diff>
--- a/A1《白穹纪元：机械永生录》/商业材料/白穹纪元路演PPT.pptx
+++ b/A1《白穹纪元：机械永生录》/商业材料/白穹纪元路演PPT.pptx
@@ -6496,45 +6496,6 @@
       </p:sp>
       <p:sp>
         <p:nvSpPr>
-          <p:cNvPr id="8" name="Text 6"/>
-          <p:cNvSpPr/>
-          <p:nvPr/>
-        </p:nvSpPr>
-        <p:spPr>
-          <a:xfrm>
-            <a:off x="548640" y="2103120"/>
-            <a:ext cx="2286000" cy="274320"/>
-          </a:xfrm>
-          <a:prstGeom prst="rect">
-            <a:avLst/>
-          </a:prstGeom>
-          <a:noFill/>
-          <a:ln/>
-        </p:spPr>
-        <p:txBody>
-          <a:bodyPr wrap="square" rtlCol="0" anchor="ctr"/>
-          <a:lstStyle/>
-          <a:p>
-            <a:pPr marL="0" indent="0">
-              <a:buNone/>
-            </a:pPr>
-            <a:r>
-              <a:rPr lang="en-US" sz="900" dirty="0">
-                <a:solidFill>
-                  <a:srgbClr val="888888"/>
-                </a:solidFill>
-                <a:latin typeface="Arial" pitchFamily="34" charset="0"/>
-                <a:ea typeface="Arial" pitchFamily="34" charset="-122"/>
-                <a:cs typeface="Arial" pitchFamily="34" charset="-120"/>
-              </a:rPr>
-              <a:t>4CAF50</a:t>
-            </a:r>
-            <a:endParaRPr lang="en-US" sz="900" dirty="0"/>
-          </a:p>
-        </p:txBody>
-      </p:sp>
-      <p:sp>
-        <p:nvSpPr>
           <p:cNvPr id="9" name="Text 7"/>
           <p:cNvSpPr/>
           <p:nvPr/>
@@ -6613,45 +6574,6 @@
       </p:sp>
       <p:sp>
         <p:nvSpPr>
-          <p:cNvPr id="11" name="Text 9"/>
-          <p:cNvSpPr/>
-          <p:nvPr/>
-        </p:nvSpPr>
-        <p:spPr>
-          <a:xfrm>
-            <a:off x="3291840" y="2103120"/>
-            <a:ext cx="2286000" cy="274320"/>
-          </a:xfrm>
-          <a:prstGeom prst="rect">
-            <a:avLst/>
-          </a:prstGeom>
-          <a:noFill/>
-          <a:ln/>
-        </p:spPr>
-        <p:txBody>
-          <a:bodyPr wrap="square" rtlCol="0" anchor="ctr"/>
-          <a:lstStyle/>
-          <a:p>
-            <a:pPr marL="0" indent="0">
-              <a:buNone/>
-            </a:pPr>
-            <a:r>
-              <a:rPr lang="en-US" sz="900" dirty="0">
-                <a:solidFill>
-                  <a:srgbClr val="888888"/>
-                </a:solidFill>
-                <a:latin typeface="Arial" pitchFamily="34" charset="0"/>
-                <a:ea typeface="Arial" pitchFamily="34" charset="-122"/>
-                <a:cs typeface="Arial" pitchFamily="34" charset="-120"/>
-              </a:rPr>
-              <a:t>D4A040</a:t>
-            </a:r>
-            <a:endParaRPr lang="en-US" sz="900" dirty="0"/>
-          </a:p>
-        </p:txBody>
-      </p:sp>
-      <p:sp>
-        <p:nvSpPr>
           <p:cNvPr id="12" name="Text 10"/>
           <p:cNvSpPr/>
           <p:nvPr/>
@@ -6723,45 +6645,6 @@
                 <a:cs typeface="Arial" pitchFamily="34" charset="-120"/>
               </a:rPr>
               <a:t>12章 裂缝之后</a:t>
-            </a:r>
-            <a:endParaRPr lang="en-US" sz="900" dirty="0"/>
-          </a:p>
-        </p:txBody>
-      </p:sp>
-      <p:sp>
-        <p:nvSpPr>
-          <p:cNvPr id="14" name="Text 12"/>
-          <p:cNvSpPr/>
-          <p:nvPr/>
-        </p:nvSpPr>
-        <p:spPr>
-          <a:xfrm>
-            <a:off x="7406640" y="2103120"/>
-            <a:ext cx="2286000" cy="274320"/>
-          </a:xfrm>
-          <a:prstGeom prst="rect">
-            <a:avLst/>
-          </a:prstGeom>
-          <a:noFill/>
-          <a:ln/>
-        </p:spPr>
-        <p:txBody>
-          <a:bodyPr wrap="square" rtlCol="0" anchor="ctr"/>
-          <a:lstStyle/>
-          <a:p>
-            <a:pPr marL="0" indent="0">
-              <a:buNone/>
-            </a:pPr>
-            <a:r>
-              <a:rPr lang="en-US" sz="900" dirty="0">
-                <a:solidFill>
-                  <a:srgbClr val="888888"/>
-                </a:solidFill>
-                <a:latin typeface="Arial" pitchFamily="34" charset="0"/>
-                <a:ea typeface="Arial" pitchFamily="34" charset="-122"/>
-                <a:cs typeface="Arial" pitchFamily="34" charset="-120"/>
-              </a:rPr>
-              <a:t>CC6633</a:t>
             </a:r>
             <a:endParaRPr lang="en-US" sz="900" dirty="0"/>
           </a:p>

</xml_diff>